<commit_message>
feat: add standalone final report and Colab pipeline
</commit_message>
<xml_diff>
--- a/outputs/slides/trabalho_volatilidade_realizada_b3.pptx
+++ b/outputs/slides/trabalho_volatilidade_realizada_b3.pptx
@@ -4264,7 +4264,7 @@
               </a:defRPr>
             </a:pPr>
             <a:r>
-              <a:t>• Nenhum evento manual verificavel foi preenchido.</a:t>
+              <a:t>• 12 eventos de earnings analisados em t-1, t e t+1.</a:t>
             </a:r>
           </a:p>
           <a:p>
@@ -4279,7 +4279,52 @@
               </a:defRPr>
             </a:pPr>
             <a:r>
+              <a:t>• RVol da janela: 16.7% acima dos dias normais.</a:t>
+            </a:r>
+          </a:p>
+          <a:p>
+            <a:pPr>
+              <a:spcAft>
+                <a:spcPts val="900"/>
+              </a:spcAft>
+              <a:defRPr sz="1600">
+                <a:solidFill>
+                  <a:srgbClr val="282C34"/>
+                </a:solidFill>
+              </a:defRPr>
+            </a:pPr>
+            <a:r>
+              <a:t>• Jump days: 25.0% nas janelas vs 17.8% nos dias normais.</a:t>
+            </a:r>
+          </a:p>
+          <a:p>
+            <a:pPr>
+              <a:spcAft>
+                <a:spcPts val="900"/>
+              </a:spcAft>
+              <a:defRPr sz="1600">
+                <a:solidFill>
+                  <a:srgbClr val="282C34"/>
+                </a:solidFill>
+              </a:defRPr>
+            </a:pPr>
+            <a:r>
               <a:t>• A pipeline nao usa scraping fragil nem inventa datas.</a:t>
+            </a:r>
+          </a:p>
+          <a:p>
+            <a:pPr>
+              <a:spcAft>
+                <a:spcPts val="900"/>
+              </a:spcAft>
+              <a:defRPr sz="1600">
+                <a:solidFill>
+                  <a:srgbClr val="282C34"/>
+                </a:solidFill>
+              </a:defRPr>
+            </a:pPr>
+            <a:r>
+              <a:t>• Evidencia descritiva; fonte terceirizada e sem identificacao causal.</a:t>
             </a:r>
           </a:p>
         </p:txBody>
@@ -4300,8 +4345,8 @@
         </p:blipFill>
         <p:spPr>
           <a:xfrm>
-            <a:off x="4892040" y="1754697"/>
-            <a:ext cx="6812280" cy="3714366"/>
+            <a:off x="4892040" y="1754838"/>
+            <a:ext cx="6812280" cy="3714083"/>
           </a:xfrm>
           <a:prstGeom prst="rect">
             <a:avLst/>

</xml_diff>

<commit_message>
docs: deepen final report and rubric audit
</commit_message>
<xml_diff>
--- a/outputs/slides/trabalho_volatilidade_realizada_b3.pptx
+++ b/outputs/slides/trabalho_volatilidade_realizada_b3.pptx
@@ -3355,7 +3355,7 @@
               </a:defRPr>
             </a:pPr>
             <a:r>
-              <a:t>• core_liquid: RVol=25.7%, jumps=11.7%.</a:t>
+              <a:t>• core_liquid: RVol=25.7%, jumps=11.0%.</a:t>
             </a:r>
           </a:p>
           <a:p>
@@ -3370,7 +3370,52 @@
               </a:defRPr>
             </a:pPr>
             <a:r>
-              <a:t>• high_vol_growth_candidate: RVol=49.4%, jumps=28.9%.</a:t>
+              <a:t>• high_vol_growth_candidate: RVol=49.4%, jumps=27.2%.</a:t>
+            </a:r>
+          </a:p>
+          <a:p>
+            <a:pPr>
+              <a:spcAft>
+                <a:spcPts val="900"/>
+              </a:spcAft>
+              <a:defRPr sz="1600">
+                <a:solidFill>
+                  <a:srgbClr val="282C34"/>
+                </a:solidFill>
+              </a:defRPr>
+            </a:pPr>
+            <a:r>
+              <a:t>• Razao de RVol complementar/core: 1.92x.</a:t>
+            </a:r>
+          </a:p>
+          <a:p>
+            <a:pPr>
+              <a:spcAft>
+                <a:spcPts val="900"/>
+              </a:spcAft>
+              <a:defRPr sz="1600">
+                <a:solidFill>
+                  <a:srgbClr val="282C34"/>
+                </a:solidFill>
+              </a:defRPr>
+            </a:pPr>
+            <a:r>
+              <a:t>• Razao da frequencia de jumps: 2.47x.</a:t>
+            </a:r>
+          </a:p>
+          <a:p>
+            <a:pPr>
+              <a:spcAft>
+                <a:spcPts val="900"/>
+              </a:spcAft>
+              <a:defRPr sz="1600">
+                <a:solidFill>
+                  <a:srgbClr val="282C34"/>
+                </a:solidFill>
+              </a:defRPr>
+            </a:pPr>
+            <a:r>
+              <a:t>• Resultado condicionado aos filtros: apenas 3 candidatas passaram.</a:t>
             </a:r>
           </a:p>
         </p:txBody>
@@ -3604,6 +3649,21 @@
               <a:t>• Diferenca economica: risco continuo versus movimentos descontínuos.</a:t>
             </a:r>
           </a:p>
+          <a:p>
+            <a:pPr>
+              <a:spcAft>
+                <a:spcPts val="900"/>
+              </a:spcAft>
+              <a:defRPr sz="1600">
+                <a:solidFill>
+                  <a:srgbClr val="282C34"/>
+                </a:solidFill>
+              </a:defRPr>
+            </a:pPr>
+            <a:r>
+              <a:t>• JV positiva nao basta: o teste usa TQ e valor critico de 99%.</a:t>
+            </a:r>
+          </a:p>
         </p:txBody>
       </p:sp>
       <p:pic>
@@ -3802,7 +3862,7 @@
               </a:defRPr>
             </a:pPr>
             <a:r>
-              <a:t>• Maior frequencia: CASH3.SA (38.3%).</a:t>
+              <a:t>• Maior frequencia: CASH3.SA (36.7%).</a:t>
             </a:r>
           </a:p>
           <a:p>
@@ -3817,7 +3877,37 @@
               </a:defRPr>
             </a:pPr>
             <a:r>
+              <a:t>• LWSA3 ficou em segundo; VALE3 e ITUB4 tiveram as menores frequencias.</a:t>
+            </a:r>
+          </a:p>
+          <a:p>
+            <a:pPr>
+              <a:spcAft>
+                <a:spcPts val="900"/>
+              </a:spcAft>
+              <a:defRPr sz="1600">
+                <a:solidFill>
+                  <a:srgbClr val="282C34"/>
+                </a:solidFill>
+              </a:defRPr>
+            </a:pPr>
+            <a:r>
               <a:t>• Jump share mede a parcela estimada de RV associada a saltos.</a:t>
+            </a:r>
+          </a:p>
+          <a:p>
+            <a:pPr>
+              <a:spcAft>
+                <a:spcPts val="900"/>
+              </a:spcAft>
+              <a:defRPr sz="1600">
+                <a:solidFill>
+                  <a:srgbClr val="282C34"/>
+                </a:solidFill>
+              </a:defRPr>
+            </a:pPr>
+            <a:r>
+              <a:t>• Jumps afetam risco de gap, execucao e stops entre observacoes.</a:t>
             </a:r>
           </a:p>
         </p:txBody>
@@ -3838,8 +3928,8 @@
         </p:blipFill>
         <p:spPr>
           <a:xfrm>
-            <a:off x="4892040" y="1653262"/>
-            <a:ext cx="6812280" cy="3917236"/>
+            <a:off x="4892040" y="1643145"/>
+            <a:ext cx="6812280" cy="3937469"/>
           </a:xfrm>
           <a:prstGeom prst="rect">
             <a:avLst/>
@@ -4063,7 +4153,37 @@
               </a:defRPr>
             </a:pPr>
             <a:r>
+              <a:t>• Maior correlacao GARCH-RVol ocorreu em B3SA3, ainda moderada.</a:t>
+            </a:r>
+          </a:p>
+          <a:p>
+            <a:pPr>
+              <a:spcAft>
+                <a:spcPts val="900"/>
+              </a:spcAft>
+              <a:defRPr sz="1600">
+                <a:solidFill>
+                  <a:srgbClr val="282C34"/>
+                </a:solidFill>
+              </a:defRPr>
+            </a:pPr>
+            <a:r>
               <a:t>• Close-to-close inclui overnight; RVol intradiaria nao.</a:t>
+            </a:r>
+          </a:p>
+          <a:p>
+            <a:pPr>
+              <a:spcAft>
+                <a:spcPts val="900"/>
+              </a:spcAft>
+              <a:defRPr sz="1600">
+                <a:solidFill>
+                  <a:srgbClr val="282C34"/>
+                </a:solidFill>
+              </a:defRPr>
+            </a:pPr>
+            <a:r>
+              <a:t>• Amostra de 59 retornos: parametros devem ser lidos com cautela.</a:t>
             </a:r>
           </a:p>
         </p:txBody>
@@ -4294,7 +4414,7 @@
               </a:defRPr>
             </a:pPr>
             <a:r>
-              <a:t>• Jump days: 25.0% nas janelas vs 17.8% nos dias normais.</a:t>
+              <a:t>• Jump days: 25.0% nas janelas vs 16.8% nos dias normais.</a:t>
             </a:r>
           </a:p>
           <a:p>
@@ -4309,7 +4429,7 @@
               </a:defRPr>
             </a:pPr>
             <a:r>
-              <a:t>• A pipeline nao usa scraping fragil nem inventa datas.</a:t>
+              <a:t>• Maior elevacao relativa em ABEV3; PETR4 ficou abaixo da media normal.</a:t>
             </a:r>
           </a:p>
           <a:p>
@@ -6207,7 +6327,7 @@
               </a:defRPr>
             </a:pPr>
             <a:r>
-              <a:t>• Timezone America/Sao_Paulo e horario regular 10:00-17:55.</a:t>
+              <a:t>• Timezone America/Sao_Paulo; teto 17:55 e fechamento efetivo 16:50.</a:t>
             </a:r>
           </a:p>
           <a:p>
@@ -6222,7 +6342,7 @@
               </a:defRPr>
             </a:pPr>
             <a:r>
-              <a:t>• Remocao de duplicatas e precos invalidos.</a:t>
+              <a:t>• Grade regular de 5 minutos com 83 candles sustentados pela fonte.</a:t>
             </a:r>
           </a:p>
           <a:p>
@@ -6237,7 +6357,7 @@
               </a:defRPr>
             </a:pPr>
             <a:r>
-              <a:t>• Grade regular de 5 minutos e ultimo preco do intervalo.</a:t>
+              <a:t>• Remocao de duplicatas e precos invalidos.</a:t>
             </a:r>
           </a:p>
           <a:p>
@@ -6253,6 +6373,21 @@
             </a:pPr>
             <a:r>
               <a:t>• Forward-fill somente dentro do dia; primeiro retorno diario removido.</a:t>
+            </a:r>
+          </a:p>
+          <a:p>
+            <a:pPr>
+              <a:spcAft>
+                <a:spcPts val="900"/>
+              </a:spcAft>
+              <a:defRPr sz="1600">
+                <a:solidFill>
+                  <a:srgbClr val="282C34"/>
+                </a:solidFill>
+              </a:defRPr>
+            </a:pPr>
+            <a:r>
+              <a:t>• Fechamento inferido evita uma cauda artificial de retornos zero.</a:t>
             </a:r>
           </a:p>
         </p:txBody>
@@ -6897,7 +7032,7 @@
               </a:defRPr>
             </a:pPr>
             <a:r>
-              <a:t>• Picos mostram mudancas rapidas do risco observado.</a:t>
+              <a:t>• Maior ticker-dia: CASH3.SA com 98.7%.</a:t>
             </a:r>
           </a:p>
           <a:p>
@@ -6912,7 +7047,37 @@
               </a:defRPr>
             </a:pPr>
             <a:r>
+              <a:t>• O maior pico nao foi jump: RV e BV subiram juntas.</a:t>
+            </a:r>
+          </a:p>
+          <a:p>
+            <a:pPr>
+              <a:spcAft>
+                <a:spcPts val="900"/>
+              </a:spcAft>
+              <a:defRPr sz="1600">
+                <a:solidFill>
+                  <a:srgbClr val="282C34"/>
+                </a:solidFill>
+              </a:defRPr>
+            </a:pPr>
+            <a:r>
               <a:t>• Persistencia visual sugere clustering de volatilidade.</a:t>
+            </a:r>
+          </a:p>
+          <a:p>
+            <a:pPr>
+              <a:spcAft>
+                <a:spcPts val="900"/>
+              </a:spcAft>
+              <a:defRPr sz="1600">
+                <a:solidFill>
+                  <a:srgbClr val="282C34"/>
+                </a:solidFill>
+              </a:defRPr>
+            </a:pPr>
+            <a:r>
+              <a:t>• Growth/high-vol opera em patamar superior ao core na maior parte da janela.</a:t>
             </a:r>
           </a:p>
         </p:txBody>
@@ -7114,6 +7279,36 @@
             </a:pPr>
             <a:r>
               <a:t>• Maior RVol anualizada media: CASH3.SA (54.4%).</a:t>
+            </a:r>
+          </a:p>
+          <a:p>
+            <a:pPr>
+              <a:spcAft>
+                <a:spcPts val="900"/>
+              </a:spcAft>
+              <a:defRPr sz="1600">
+                <a:solidFill>
+                  <a:srgbClr val="282C34"/>
+                </a:solidFill>
+              </a:defRPr>
+            </a:pPr>
+            <a:r>
+              <a:t>• CASH3, LWSA3 e MGLU3 ocupam as tres primeiras posicoes.</a:t>
+            </a:r>
+          </a:p>
+          <a:p>
+            <a:pPr>
+              <a:spcAft>
+                <a:spcPts val="900"/>
+              </a:spcAft>
+              <a:defRPr sz="1600">
+                <a:solidFill>
+                  <a:srgbClr val="282C34"/>
+                </a:solidFill>
+              </a:defRPr>
+            </a:pPr>
+            <a:r>
+              <a:t>• TOTS3 e o ativo core de maior volatilidade media.</a:t>
             </a:r>
           </a:p>
           <a:p>

</xml_diff>